<commit_message>
Frontend Setup- Master forget password page
</commit_message>
<xml_diff>
--- a/.lessons/51 Frontend Template Setup And Mastering/2 Frontend Setup- Template mastering (part - 2)/1.pptx
+++ b/.lessons/51 Frontend Template Setup And Mastering/2 Frontend Setup- Template mastering (part - 2)/1.pptx
@@ -7,7 +7,16 @@
   <p:sldIdLst>
     <p:sldId id="413" r:id="rId2"/>
     <p:sldId id="414" r:id="rId3"/>
-    <p:sldId id="400" r:id="rId4"/>
+    <p:sldId id="415" r:id="rId4"/>
+    <p:sldId id="416" r:id="rId5"/>
+    <p:sldId id="417" r:id="rId6"/>
+    <p:sldId id="419" r:id="rId7"/>
+    <p:sldId id="420" r:id="rId8"/>
+    <p:sldId id="422" r:id="rId9"/>
+    <p:sldId id="423" r:id="rId10"/>
+    <p:sldId id="421" r:id="rId11"/>
+    <p:sldId id="418" r:id="rId12"/>
+    <p:sldId id="400" r:id="rId13"/>
   </p:sldIdLst>
   <p:sldSz cx="12192000" cy="6858000"/>
   <p:notesSz cx="6858000" cy="9144000"/>
@@ -114,6 +123,174 @@
 </p:presentation>
 </file>
 
+<file path=ppt/ink/ink1.xml><?xml version="1.0" encoding="utf-8"?>
+<inkml:ink xmlns:inkml="http://www.w3.org/2003/InkML">
+  <inkml:definitions>
+    <inkml:context xml:id="ctx0">
+      <inkml:inkSource xml:id="inkSrc0">
+        <inkml:traceFormat>
+          <inkml:channel name="X" type="integer" min="-2.14748E9" max="2.14748E9" units="cm"/>
+          <inkml:channel name="Y" type="integer" min="-2.14748E9" max="2.14748E9" units="cm"/>
+          <inkml:channel name="F" type="integer" max="32767" units="dev"/>
+        </inkml:traceFormat>
+        <inkml:channelProperties>
+          <inkml:channelProperty channel="X" name="resolution" value="1000" units="1/cm"/>
+          <inkml:channelProperty channel="Y" name="resolution" value="1000" units="1/cm"/>
+          <inkml:channelProperty channel="F" name="resolution" value="0" units="1/dev"/>
+        </inkml:channelProperties>
+      </inkml:inkSource>
+      <inkml:timestamp xml:id="ts0" timeString="2025-07-29T14:06:16.972"/>
+    </inkml:context>
+    <inkml:brush xml:id="br0">
+      <inkml:brushProperty name="width" value="0.035" units="cm"/>
+      <inkml:brushProperty name="height" value="0.035" units="cm"/>
+      <inkml:brushProperty name="color" value="#E71224"/>
+    </inkml:brush>
+  </inkml:definitions>
+  <inkml:trace contextRef="#ctx0" brushRef="#br0">2006 4 24575,'0'0'0,"-1"0"0,1 0 0,0-1 0,0 1 0,0 0 0,-1-1 0,1 1 0,0 0 0,0 0 0,-1 0 0,1-1 0,0 1 0,-1 0 0,1 0 0,0 0 0,0 0 0,-1 0 0,1-1 0,0 1 0,-1 0 0,1 0 0,0 0 0,-1 0 0,1 0 0,0 0 0,-1 0 0,1 0 0,0 0 0,-1 0 0,1 0 0,0 1 0,-1-1 0,1 0 0,0 0 0,-1 0 0,1 0 0,0 0 0,0 1 0,-1-1 0,1 0 0,0 0 0,-1 0 0,1 1 0,0-1 0,0 0 0,0 0 0,-1 1 0,1-1 0,0 0 0,0 1 0,0-1 0,-7 23 0,6-16 0,-89 287 0,55-183 0,-59 127 0,57-153 0,-31 109 0,45-122 0,-4 0 0,-62 120 0,51-104 0,28-61 0,-2 0 0,-20 36 0,-68 117 0,16-27 0,75-140 0,0-1 0,0 0 0,-15 13 0,-24 32 0,2 5 0,-3-3 0,-1-1 0,-95 81 0,86-85 0,1 3 0,3 2 0,-51 73 0,79-98 0,-2 0 0,-1-2 0,-1-1 0,-47 35 0,43-38 0,2 1 0,1 1 0,2 2 0,-36 46 0,38-38 0,-53 54 0,72-84-3,0 2 0,1-1 0,1 1 0,-9 18 0,-1 1-1347,5-11-5476</inkml:trace>
+</inkml:ink>
+</file>
+
+<file path=ppt/ink/ink2.xml><?xml version="1.0" encoding="utf-8"?>
+<inkml:ink xmlns:inkml="http://www.w3.org/2003/InkML">
+  <inkml:definitions>
+    <inkml:context xml:id="ctx0">
+      <inkml:inkSource xml:id="inkSrc0">
+        <inkml:traceFormat>
+          <inkml:channel name="X" type="integer" min="-2.14748E9" max="2.14748E9" units="cm"/>
+          <inkml:channel name="Y" type="integer" min="-2.14748E9" max="2.14748E9" units="cm"/>
+          <inkml:channel name="F" type="integer" max="32767" units="dev"/>
+        </inkml:traceFormat>
+        <inkml:channelProperties>
+          <inkml:channelProperty channel="X" name="resolution" value="1000" units="1/cm"/>
+          <inkml:channelProperty channel="Y" name="resolution" value="1000" units="1/cm"/>
+          <inkml:channelProperty channel="F" name="resolution" value="0" units="1/dev"/>
+        </inkml:channelProperties>
+      </inkml:inkSource>
+      <inkml:timestamp xml:id="ts0" timeString="2025-07-29T14:06:18.240"/>
+    </inkml:context>
+    <inkml:brush xml:id="br0">
+      <inkml:brushProperty name="width" value="0.035" units="cm"/>
+      <inkml:brushProperty name="height" value="0.035" units="cm"/>
+      <inkml:brushProperty name="color" value="#E71224"/>
+    </inkml:brush>
+  </inkml:definitions>
+  <inkml:trace contextRef="#ctx0" brushRef="#br0">50 1 24575,'-1'12'0,"0"0"0,-1 1 0,-6 18 0,-3 24 0,-1 25 0,6-54 0,-2 54 0,8-78 0,0 0 0,0 0 0,0 0 0,1 0 0,-1 0 0,1 0 0,-1 0 0,1 0 0,0 0 0,-1 0 0,1 0 0,0 0 0,1-1 0,-1 1 0,0 0 0,0 0 0,1-1 0,-1 1 0,1-1 0,-1 0 0,3 2 0,0 0 0,0-1 0,0 0 0,1 0 0,-1 0 0,1-1 0,-1 1 0,1-1 0,0 0 0,4 0 0,6 0 0,0 0 0,0-1 0,-1-1 0,1 0 0,18-5 0,48-17-1365,-59 14-5461</inkml:trace>
+</inkml:ink>
+</file>
+
+<file path=ppt/ink/ink3.xml><?xml version="1.0" encoding="utf-8"?>
+<inkml:ink xmlns:inkml="http://www.w3.org/2003/InkML">
+  <inkml:definitions>
+    <inkml:context xml:id="ctx0">
+      <inkml:inkSource xml:id="inkSrc0">
+        <inkml:traceFormat>
+          <inkml:channel name="X" type="integer" min="-2.14748E9" max="2.14748E9" units="cm"/>
+          <inkml:channel name="Y" type="integer" min="-2.14748E9" max="2.14748E9" units="cm"/>
+          <inkml:channel name="F" type="integer" max="32767" units="dev"/>
+        </inkml:traceFormat>
+        <inkml:channelProperties>
+          <inkml:channelProperty channel="X" name="resolution" value="1000" units="1/cm"/>
+          <inkml:channelProperty channel="Y" name="resolution" value="1000" units="1/cm"/>
+          <inkml:channelProperty channel="F" name="resolution" value="0" units="1/dev"/>
+        </inkml:channelProperties>
+      </inkml:inkSource>
+      <inkml:timestamp xml:id="ts0" timeString="2025-07-29T14:06:20.460"/>
+    </inkml:context>
+    <inkml:brush xml:id="br0">
+      <inkml:brushProperty name="width" value="0.035" units="cm"/>
+      <inkml:brushProperty name="height" value="0.035" units="cm"/>
+      <inkml:brushProperty name="color" value="#E71224"/>
+    </inkml:brush>
+  </inkml:definitions>
+  <inkml:trace contextRef="#ctx0" brushRef="#br0">6266 0 24575,'-53'117'0,"-6"-2"0,-88 129 0,129-215 0,-500 734 0,391-582 0,-340 454 0,216-301 0,-173 188 0,180-230 0,176-214 0,-87 78 0,-91 60 0,212-186 0,-347 276 0,-530 326 0,406-371 0,332-179 0,96-50 0,-119 35 0,111-41 0,-82 37 0,-268 114 100,-62 30-1565,469-193-5361</inkml:trace>
+</inkml:ink>
+</file>
+
+<file path=ppt/ink/ink4.xml><?xml version="1.0" encoding="utf-8"?>
+<inkml:ink xmlns:inkml="http://www.w3.org/2003/InkML">
+  <inkml:definitions>
+    <inkml:context xml:id="ctx0">
+      <inkml:inkSource xml:id="inkSrc0">
+        <inkml:traceFormat>
+          <inkml:channel name="X" type="integer" min="-2.14748E9" max="2.14748E9" units="cm"/>
+          <inkml:channel name="Y" type="integer" min="-2.14748E9" max="2.14748E9" units="cm"/>
+          <inkml:channel name="F" type="integer" max="32767" units="dev"/>
+        </inkml:traceFormat>
+        <inkml:channelProperties>
+          <inkml:channelProperty channel="X" name="resolution" value="1000" units="1/cm"/>
+          <inkml:channelProperty channel="Y" name="resolution" value="1000" units="1/cm"/>
+          <inkml:channelProperty channel="F" name="resolution" value="0" units="1/dev"/>
+        </inkml:channelProperties>
+      </inkml:inkSource>
+      <inkml:timestamp xml:id="ts0" timeString="2025-07-29T14:06:21.539"/>
+    </inkml:context>
+    <inkml:brush xml:id="br0">
+      <inkml:brushProperty name="width" value="0.035" units="cm"/>
+      <inkml:brushProperty name="height" value="0.035" units="cm"/>
+      <inkml:brushProperty name="color" value="#E71224"/>
+    </inkml:brush>
+  </inkml:definitions>
+  <inkml:trace contextRef="#ctx0" brushRef="#br0">127 1 24575,'-1'3'0,"-1"1"0,1-1 0,-1 0 0,1 1 0,-1-1 0,0 0 0,0 0 0,-1 0 0,-1 3 0,-8 10 0,-1 7 0,2-1 0,0 1 0,2 1 0,1 0 0,0 1 0,-5 33 0,4-15 0,5-27 0,1-1 0,0 1 0,2 0 0,-1 0 0,2 24 0,1-36 0,-1-1 0,1 1 0,0 0 0,0-1 0,0 1 0,0-1 0,1 1 0,-1-1 0,1 0 0,0 0 0,0 0 0,0 0 0,1 0 0,-1 0 0,1 0 0,-1-1 0,1 1 0,0-1 0,0 0 0,0 0 0,0 0 0,0 0 0,1 0 0,-1-1 0,0 0 0,1 1 0,-1-1 0,8 1 0,243 44 0,-230-42-341,-1 1 0,0 1-1,41 16 1,-41-12-6485</inkml:trace>
+</inkml:ink>
+</file>
+
+<file path=ppt/ink/ink5.xml><?xml version="1.0" encoding="utf-8"?>
+<inkml:ink xmlns:inkml="http://www.w3.org/2003/InkML">
+  <inkml:definitions>
+    <inkml:context xml:id="ctx0">
+      <inkml:inkSource xml:id="inkSrc0">
+        <inkml:traceFormat>
+          <inkml:channel name="X" type="integer" min="-2.14748E9" max="2.14748E9" units="cm"/>
+          <inkml:channel name="Y" type="integer" min="-2.14748E9" max="2.14748E9" units="cm"/>
+          <inkml:channel name="F" type="integer" max="32767" units="dev"/>
+        </inkml:traceFormat>
+        <inkml:channelProperties>
+          <inkml:channelProperty channel="X" name="resolution" value="1000" units="1/cm"/>
+          <inkml:channelProperty channel="Y" name="resolution" value="1000" units="1/cm"/>
+          <inkml:channelProperty channel="F" name="resolution" value="0" units="1/dev"/>
+        </inkml:channelProperties>
+      </inkml:inkSource>
+      <inkml:timestamp xml:id="ts0" timeString="2025-07-29T14:06:23.558"/>
+    </inkml:context>
+    <inkml:brush xml:id="br0">
+      <inkml:brushProperty name="width" value="0.035" units="cm"/>
+      <inkml:brushProperty name="height" value="0.035" units="cm"/>
+      <inkml:brushProperty name="color" value="#E71224"/>
+    </inkml:brush>
+  </inkml:definitions>
+  <inkml:trace contextRef="#ctx0" brushRef="#br0">14020 1 24575,'-5'3'0,"1"0"0,0 0 0,-1 1 0,1 0 0,1 0 0,-1 0 0,1 1 0,0-1 0,0 1 0,-5 8 0,1-2 0,-95 157 0,-96 146 0,-71 60-194,-15-12 0,-17-12 0,-475 428-1,549-586-256,-429 279 0,-296 95-284,748-450 886,176-100-169,-878 529-473,-435 233 491,769-489 573,-814 405 1626,472-298-2199,633-281 0,-233 81 0,-630 151 0,89 2 0,789-261 0,158-56 0,-128 58 0,-28 29 0,-233 114 0,285-145 0,93-43 0,108-39 22,1 0 1,0 0-1,1 1 0,-1 0 0,-14 15 1,13-13-398,1 1 0,-2-1 1,-14 9-1,5-8-6451</inkml:trace>
+</inkml:ink>
+</file>
+
+<file path=ppt/ink/ink6.xml><?xml version="1.0" encoding="utf-8"?>
+<inkml:ink xmlns:inkml="http://www.w3.org/2003/InkML">
+  <inkml:definitions>
+    <inkml:context xml:id="ctx0">
+      <inkml:inkSource xml:id="inkSrc0">
+        <inkml:traceFormat>
+          <inkml:channel name="X" type="integer" min="-2.14748E9" max="2.14748E9" units="cm"/>
+          <inkml:channel name="Y" type="integer" min="-2.14748E9" max="2.14748E9" units="cm"/>
+          <inkml:channel name="F" type="integer" max="32767" units="dev"/>
+        </inkml:traceFormat>
+        <inkml:channelProperties>
+          <inkml:channelProperty channel="X" name="resolution" value="1000" units="1/cm"/>
+          <inkml:channelProperty channel="Y" name="resolution" value="1000" units="1/cm"/>
+          <inkml:channelProperty channel="F" name="resolution" value="0" units="1/dev"/>
+        </inkml:channelProperties>
+      </inkml:inkSource>
+      <inkml:timestamp xml:id="ts0" timeString="2025-07-29T14:06:24.437"/>
+    </inkml:context>
+    <inkml:brush xml:id="br0">
+      <inkml:brushProperty name="width" value="0.035" units="cm"/>
+      <inkml:brushProperty name="height" value="0.035" units="cm"/>
+      <inkml:brushProperty name="color" value="#E71224"/>
+    </inkml:brush>
+  </inkml:definitions>
+  <inkml:trace contextRef="#ctx0" brushRef="#br0">131 0 24575,'-4'3'0,"-1"0"0,1 1 0,0 0 0,0-1 0,0 1 0,0 1 0,1-1 0,-1 0 0,1 1 0,0 0 0,-2 5 0,3-7 0,-4 9 0,0 1 0,1 0 0,0 0 0,1 0 0,-5 25 0,-8 26 0,11-47 0,0 0 0,1 0 0,1 1 0,1-1 0,0 1 0,2 0 0,-1 28 0,3-44 0,-1 1 0,1-1 0,0 0 0,0 1 0,0-1 0,0 0 0,0 1 0,0-1 0,0 0 0,1 0 0,-1 0 0,1 0 0,0 0 0,0 0 0,-1-1 0,1 1 0,0-1 0,0 1 0,0-1 0,1 0 0,-1 0 0,0 1 0,0-1 0,1-1 0,-1 1 0,1 0 0,-1-1 0,5 1 0,9 2 0,0-1 0,1-1 0,21 0 0,-19-1 0,240-3-1365,-202 2-5461</inkml:trace>
+</inkml:ink>
+</file>
+
 <file path=ppt/slideLayouts/slideLayout1.xml><?xml version="1.0" encoding="utf-8"?>
 <p:sldLayout xmlns:a="http://schemas.openxmlformats.org/drawingml/2006/main" xmlns:r="http://schemas.openxmlformats.org/officeDocument/2006/relationships" xmlns:p="http://schemas.openxmlformats.org/presentationml/2006/main" type="title" preserve="1">
   <p:cSld name="Title Slide">
@@ -261,7 +438,7 @@
           <a:p>
             <a:fld id="{3E102D2E-813C-461C-9963-687A650C48C0}" type="datetimeFigureOut">
               <a:rPr lang="en-US" smtClean="0"/>
-              <a:t>6/26/2025</a:t>
+              <a:t>7/29/2025</a:t>
             </a:fld>
             <a:endParaRPr lang="en-US"/>
           </a:p>
@@ -459,7 +636,7 @@
           <a:p>
             <a:fld id="{3E102D2E-813C-461C-9963-687A650C48C0}" type="datetimeFigureOut">
               <a:rPr lang="en-US" smtClean="0"/>
-              <a:t>6/26/2025</a:t>
+              <a:t>7/29/2025</a:t>
             </a:fld>
             <a:endParaRPr lang="en-US"/>
           </a:p>
@@ -667,7 +844,7 @@
           <a:p>
             <a:fld id="{3E102D2E-813C-461C-9963-687A650C48C0}" type="datetimeFigureOut">
               <a:rPr lang="en-US" smtClean="0"/>
-              <a:t>6/26/2025</a:t>
+              <a:t>7/29/2025</a:t>
             </a:fld>
             <a:endParaRPr lang="en-US"/>
           </a:p>
@@ -865,7 +1042,7 @@
           <a:p>
             <a:fld id="{3E102D2E-813C-461C-9963-687A650C48C0}" type="datetimeFigureOut">
               <a:rPr lang="en-US" smtClean="0"/>
-              <a:t>6/26/2025</a:t>
+              <a:t>7/29/2025</a:t>
             </a:fld>
             <a:endParaRPr lang="en-US"/>
           </a:p>
@@ -1140,7 +1317,7 @@
           <a:p>
             <a:fld id="{3E102D2E-813C-461C-9963-687A650C48C0}" type="datetimeFigureOut">
               <a:rPr lang="en-US" smtClean="0"/>
-              <a:t>6/26/2025</a:t>
+              <a:t>7/29/2025</a:t>
             </a:fld>
             <a:endParaRPr lang="en-US"/>
           </a:p>
@@ -1405,7 +1582,7 @@
           <a:p>
             <a:fld id="{3E102D2E-813C-461C-9963-687A650C48C0}" type="datetimeFigureOut">
               <a:rPr lang="en-US" smtClean="0"/>
-              <a:t>6/26/2025</a:t>
+              <a:t>7/29/2025</a:t>
             </a:fld>
             <a:endParaRPr lang="en-US"/>
           </a:p>
@@ -1817,7 +1994,7 @@
           <a:p>
             <a:fld id="{3E102D2E-813C-461C-9963-687A650C48C0}" type="datetimeFigureOut">
               <a:rPr lang="en-US" smtClean="0"/>
-              <a:t>6/26/2025</a:t>
+              <a:t>7/29/2025</a:t>
             </a:fld>
             <a:endParaRPr lang="en-US"/>
           </a:p>
@@ -1958,7 +2135,7 @@
           <a:p>
             <a:fld id="{3E102D2E-813C-461C-9963-687A650C48C0}" type="datetimeFigureOut">
               <a:rPr lang="en-US" smtClean="0"/>
-              <a:t>6/26/2025</a:t>
+              <a:t>7/29/2025</a:t>
             </a:fld>
             <a:endParaRPr lang="en-US"/>
           </a:p>
@@ -2071,7 +2248,7 @@
           <a:p>
             <a:fld id="{3E102D2E-813C-461C-9963-687A650C48C0}" type="datetimeFigureOut">
               <a:rPr lang="en-US" smtClean="0"/>
-              <a:t>6/26/2025</a:t>
+              <a:t>7/29/2025</a:t>
             </a:fld>
             <a:endParaRPr lang="en-US"/>
           </a:p>
@@ -2382,7 +2559,7 @@
           <a:p>
             <a:fld id="{3E102D2E-813C-461C-9963-687A650C48C0}" type="datetimeFigureOut">
               <a:rPr lang="en-US" smtClean="0"/>
-              <a:t>6/26/2025</a:t>
+              <a:t>7/29/2025</a:t>
             </a:fld>
             <a:endParaRPr lang="en-US"/>
           </a:p>
@@ -2670,7 +2847,7 @@
           <a:p>
             <a:fld id="{3E102D2E-813C-461C-9963-687A650C48C0}" type="datetimeFigureOut">
               <a:rPr lang="en-US" smtClean="0"/>
-              <a:t>6/26/2025</a:t>
+              <a:t>7/29/2025</a:t>
             </a:fld>
             <a:endParaRPr lang="en-US"/>
           </a:p>
@@ -2911,7 +3088,7 @@
           <a:p>
             <a:fld id="{3E102D2E-813C-461C-9963-687A650C48C0}" type="datetimeFigureOut">
               <a:rPr lang="en-US" smtClean="0"/>
-              <a:t>6/26/2025</a:t>
+              <a:t>7/29/2025</a:t>
             </a:fld>
             <a:endParaRPr lang="en-US"/>
           </a:p>
@@ -3369,6 +3546,155 @@
               <a:buNone/>
             </a:pPr>
             <a:r>
+              <a:rPr lang="en-US" altLang="en-US" sz="1300">
+                <a:latin typeface="Arial" panose="020B0604020202020204" pitchFamily="34" charset="0"/>
+              </a:rPr>
+              <a:t>`</a:t>
+            </a:r>
+            <a:r>
+              <a:rPr lang="en-US" altLang="en-US" sz="1300" b="1">
+                <a:latin typeface="Arial" panose="020B0604020202020204" pitchFamily="34" charset="0"/>
+              </a:rPr>
+              <a:t>resources\views\frontend\home\home.blade.php</a:t>
+            </a:r>
+            <a:r>
+              <a:rPr lang="en-US" altLang="en-US" sz="1300">
+                <a:latin typeface="Arial" panose="020B0604020202020204" pitchFamily="34" charset="0"/>
+              </a:rPr>
+              <a:t>` </a:t>
+            </a:r>
+            <a:r>
+              <a:rPr lang="az-Latn-AZ" altLang="en-US" sz="1300">
+                <a:latin typeface="Arial" panose="020B0604020202020204" pitchFamily="34" charset="0"/>
+              </a:rPr>
+              <a:t>faylındakı kodları, `</a:t>
+            </a:r>
+            <a:r>
+              <a:rPr lang="en-US" altLang="en-US" sz="1300" b="1">
+                <a:latin typeface="Arial" panose="020B0604020202020204" pitchFamily="34" charset="0"/>
+              </a:rPr>
+              <a:t>resources\views\frontend\layouts\master.blade.php</a:t>
+            </a:r>
+            <a:r>
+              <a:rPr lang="az-Latn-AZ" altLang="en-US" sz="1300">
+                <a:latin typeface="Arial" panose="020B0604020202020204" pitchFamily="34" charset="0"/>
+              </a:rPr>
+              <a:t>` faylına köçürürük.</a:t>
+            </a:r>
+            <a:endParaRPr kumimoji="0" lang="en-US" altLang="en-US" sz="1300" b="0" i="0" u="none" strike="noStrike" cap="none" normalizeH="0" baseline="0">
+              <a:ln>
+                <a:noFill/>
+              </a:ln>
+              <a:solidFill>
+                <a:schemeClr val="tx1"/>
+              </a:solidFill>
+              <a:effectLst/>
+              <a:latin typeface="Arial" panose="020B0604020202020204" pitchFamily="34" charset="0"/>
+            </a:endParaRPr>
+          </a:p>
+        </p:txBody>
+      </p:sp>
+      <p:pic>
+        <p:nvPicPr>
+          <p:cNvPr id="4" name="Picture 3">
+            <a:extLst>
+              <a:ext uri="{FF2B5EF4-FFF2-40B4-BE49-F238E27FC236}">
+                <a16:creationId xmlns:a16="http://schemas.microsoft.com/office/drawing/2014/main" id="{977313F4-3064-DC3F-591D-0D9E7BD05404}"/>
+              </a:ext>
+            </a:extLst>
+          </p:cNvPr>
+          <p:cNvPicPr>
+            <a:picLocks noChangeAspect="1"/>
+          </p:cNvPicPr>
+          <p:nvPr/>
+        </p:nvPicPr>
+        <p:blipFill>
+          <a:blip r:embed="rId2"/>
+          <a:stretch>
+            <a:fillRect/>
+          </a:stretch>
+        </p:blipFill>
+        <p:spPr>
+          <a:xfrm>
+            <a:off x="-1" y="2204763"/>
+            <a:ext cx="12192000" cy="4653237"/>
+          </a:xfrm>
+          <a:prstGeom prst="rect">
+            <a:avLst/>
+          </a:prstGeom>
+        </p:spPr>
+      </p:pic>
+    </p:spTree>
+    <p:extLst>
+      <p:ext uri="{BB962C8B-B14F-4D97-AF65-F5344CB8AC3E}">
+        <p14:creationId xmlns:p14="http://schemas.microsoft.com/office/powerpoint/2010/main" val="3863838039"/>
+      </p:ext>
+    </p:extLst>
+  </p:cSld>
+  <p:clrMapOvr>
+    <a:masterClrMapping/>
+  </p:clrMapOvr>
+</p:sld>
+</file>
+
+<file path=ppt/slides/slide10.xml><?xml version="1.0" encoding="utf-8"?>
+<p:sld xmlns:a="http://schemas.openxmlformats.org/drawingml/2006/main" xmlns:r="http://schemas.openxmlformats.org/officeDocument/2006/relationships" xmlns:p="http://schemas.openxmlformats.org/presentationml/2006/main">
+  <p:cSld>
+    <p:spTree>
+      <p:nvGrpSpPr>
+        <p:cNvPr id="1" name="">
+          <a:extLst>
+            <a:ext uri="{FF2B5EF4-FFF2-40B4-BE49-F238E27FC236}">
+              <a16:creationId xmlns:a16="http://schemas.microsoft.com/office/drawing/2014/main" id="{FF765347-A0EA-B268-0F11-EEC8E3A9FE8F}"/>
+            </a:ext>
+          </a:extLst>
+        </p:cNvPr>
+        <p:cNvGrpSpPr/>
+        <p:nvPr/>
+      </p:nvGrpSpPr>
+      <p:grpSpPr>
+        <a:xfrm>
+          <a:off x="0" y="0"/>
+          <a:ext cx="0" cy="0"/>
+          <a:chOff x="0" y="0"/>
+          <a:chExt cx="0" cy="0"/>
+        </a:xfrm>
+      </p:grpSpPr>
+      <p:sp>
+        <p:nvSpPr>
+          <p:cNvPr id="3" name="TextBox 2">
+            <a:extLst>
+              <a:ext uri="{FF2B5EF4-FFF2-40B4-BE49-F238E27FC236}">
+                <a16:creationId xmlns:a16="http://schemas.microsoft.com/office/drawing/2014/main" id="{BA81D969-4E0A-EA5F-8BA0-AB5063301D0A}"/>
+              </a:ext>
+            </a:extLst>
+          </p:cNvPr>
+          <p:cNvSpPr txBox="1"/>
+          <p:nvPr/>
+        </p:nvSpPr>
+        <p:spPr>
+          <a:xfrm>
+            <a:off x="217714" y="255046"/>
+            <a:ext cx="11756571" cy="355354"/>
+          </a:xfrm>
+          <a:prstGeom prst="rect">
+            <a:avLst/>
+          </a:prstGeom>
+          <a:noFill/>
+        </p:spPr>
+        <p:txBody>
+          <a:bodyPr wrap="square">
+            <a:spAutoFit/>
+          </a:bodyPr>
+          <a:lstStyle/>
+          <a:p>
+            <a:pPr>
+              <a:lnSpc>
+                <a:spcPct val="150000"/>
+              </a:lnSpc>
+              <a:buNone/>
+            </a:pPr>
+            <a:r>
               <a:rPr kumimoji="0" lang="en-US" altLang="en-US" sz="1300" b="0" i="0" u="none" strike="noStrike" cap="none" normalizeH="0" baseline="0">
                 <a:ln>
                   <a:noFill/>
@@ -3387,7 +3713,179 @@
     </p:spTree>
     <p:extLst>
       <p:ext uri="{BB962C8B-B14F-4D97-AF65-F5344CB8AC3E}">
-        <p14:creationId xmlns:p14="http://schemas.microsoft.com/office/powerpoint/2010/main" val="3863838039"/>
+        <p14:creationId xmlns:p14="http://schemas.microsoft.com/office/powerpoint/2010/main" val="1465870577"/>
+      </p:ext>
+    </p:extLst>
+  </p:cSld>
+  <p:clrMapOvr>
+    <a:masterClrMapping/>
+  </p:clrMapOvr>
+</p:sld>
+</file>
+
+<file path=ppt/slides/slide11.xml><?xml version="1.0" encoding="utf-8"?>
+<p:sld xmlns:a="http://schemas.openxmlformats.org/drawingml/2006/main" xmlns:r="http://schemas.openxmlformats.org/officeDocument/2006/relationships" xmlns:p="http://schemas.openxmlformats.org/presentationml/2006/main">
+  <p:cSld>
+    <p:spTree>
+      <p:nvGrpSpPr>
+        <p:cNvPr id="1" name="">
+          <a:extLst>
+            <a:ext uri="{FF2B5EF4-FFF2-40B4-BE49-F238E27FC236}">
+              <a16:creationId xmlns:a16="http://schemas.microsoft.com/office/drawing/2014/main" id="{08ED8182-8429-6508-99C4-6BE16E42D01C}"/>
+            </a:ext>
+          </a:extLst>
+        </p:cNvPr>
+        <p:cNvGrpSpPr/>
+        <p:nvPr/>
+      </p:nvGrpSpPr>
+      <p:grpSpPr>
+        <a:xfrm>
+          <a:off x="0" y="0"/>
+          <a:ext cx="0" cy="0"/>
+          <a:chOff x="0" y="0"/>
+          <a:chExt cx="0" cy="0"/>
+        </a:xfrm>
+      </p:grpSpPr>
+      <p:sp>
+        <p:nvSpPr>
+          <p:cNvPr id="3" name="TextBox 2">
+            <a:extLst>
+              <a:ext uri="{FF2B5EF4-FFF2-40B4-BE49-F238E27FC236}">
+                <a16:creationId xmlns:a16="http://schemas.microsoft.com/office/drawing/2014/main" id="{198734D9-1F3D-E032-349D-D19376BDCA60}"/>
+              </a:ext>
+            </a:extLst>
+          </p:cNvPr>
+          <p:cNvSpPr txBox="1"/>
+          <p:nvPr/>
+        </p:nvSpPr>
+        <p:spPr>
+          <a:xfrm>
+            <a:off x="217714" y="255046"/>
+            <a:ext cx="11756571" cy="355354"/>
+          </a:xfrm>
+          <a:prstGeom prst="rect">
+            <a:avLst/>
+          </a:prstGeom>
+          <a:noFill/>
+        </p:spPr>
+        <p:txBody>
+          <a:bodyPr wrap="square">
+            <a:spAutoFit/>
+          </a:bodyPr>
+          <a:lstStyle/>
+          <a:p>
+            <a:pPr>
+              <a:lnSpc>
+                <a:spcPct val="150000"/>
+              </a:lnSpc>
+              <a:buNone/>
+            </a:pPr>
+            <a:r>
+              <a:rPr kumimoji="0" lang="en-US" altLang="en-US" sz="1300" b="0" i="0" u="none" strike="noStrike" cap="none" normalizeH="0" baseline="0">
+                <a:ln>
+                  <a:noFill/>
+                </a:ln>
+                <a:solidFill>
+                  <a:schemeClr val="tx1"/>
+                </a:solidFill>
+                <a:effectLst/>
+                <a:latin typeface="Arial" panose="020B0604020202020204" pitchFamily="34" charset="0"/>
+              </a:rPr>
+              <a:t>.</a:t>
+            </a:r>
+          </a:p>
+        </p:txBody>
+      </p:sp>
+    </p:spTree>
+    <p:extLst>
+      <p:ext uri="{BB962C8B-B14F-4D97-AF65-F5344CB8AC3E}">
+        <p14:creationId xmlns:p14="http://schemas.microsoft.com/office/powerpoint/2010/main" val="2835448902"/>
+      </p:ext>
+    </p:extLst>
+  </p:cSld>
+  <p:clrMapOvr>
+    <a:masterClrMapping/>
+  </p:clrMapOvr>
+</p:sld>
+</file>
+
+<file path=ppt/slides/slide12.xml><?xml version="1.0" encoding="utf-8"?>
+<p:sld xmlns:a="http://schemas.openxmlformats.org/drawingml/2006/main" xmlns:r="http://schemas.openxmlformats.org/officeDocument/2006/relationships" xmlns:p="http://schemas.openxmlformats.org/presentationml/2006/main">
+  <p:cSld>
+    <p:spTree>
+      <p:nvGrpSpPr>
+        <p:cNvPr id="1" name="">
+          <a:extLst>
+            <a:ext uri="{FF2B5EF4-FFF2-40B4-BE49-F238E27FC236}">
+              <a16:creationId xmlns:a16="http://schemas.microsoft.com/office/drawing/2014/main" id="{ECE25D7D-A080-F22B-7E8D-36EC827289A1}"/>
+            </a:ext>
+          </a:extLst>
+        </p:cNvPr>
+        <p:cNvGrpSpPr/>
+        <p:nvPr/>
+      </p:nvGrpSpPr>
+      <p:grpSpPr>
+        <a:xfrm>
+          <a:off x="0" y="0"/>
+          <a:ext cx="0" cy="0"/>
+          <a:chOff x="0" y="0"/>
+          <a:chExt cx="0" cy="0"/>
+        </a:xfrm>
+      </p:grpSpPr>
+      <p:sp>
+        <p:nvSpPr>
+          <p:cNvPr id="3" name="TextBox 2">
+            <a:extLst>
+              <a:ext uri="{FF2B5EF4-FFF2-40B4-BE49-F238E27FC236}">
+                <a16:creationId xmlns:a16="http://schemas.microsoft.com/office/drawing/2014/main" id="{E33F16A3-A6E8-401E-847B-09570DC6E4CB}"/>
+              </a:ext>
+            </a:extLst>
+          </p:cNvPr>
+          <p:cNvSpPr txBox="1"/>
+          <p:nvPr/>
+        </p:nvSpPr>
+        <p:spPr>
+          <a:xfrm>
+            <a:off x="217714" y="255046"/>
+            <a:ext cx="11756571" cy="355354"/>
+          </a:xfrm>
+          <a:prstGeom prst="rect">
+            <a:avLst/>
+          </a:prstGeom>
+          <a:noFill/>
+        </p:spPr>
+        <p:txBody>
+          <a:bodyPr wrap="square">
+            <a:spAutoFit/>
+          </a:bodyPr>
+          <a:lstStyle/>
+          <a:p>
+            <a:pPr>
+              <a:lnSpc>
+                <a:spcPct val="150000"/>
+              </a:lnSpc>
+              <a:buNone/>
+            </a:pPr>
+            <a:r>
+              <a:rPr kumimoji="0" lang="en-US" altLang="en-US" sz="1300" b="0" i="0" u="none" strike="noStrike" cap="none" normalizeH="0" baseline="0">
+                <a:ln>
+                  <a:noFill/>
+                </a:ln>
+                <a:solidFill>
+                  <a:schemeClr val="tx1"/>
+                </a:solidFill>
+                <a:effectLst/>
+                <a:latin typeface="Arial" panose="020B0604020202020204" pitchFamily="34" charset="0"/>
+              </a:rPr>
+              <a:t>.</a:t>
+            </a:r>
+          </a:p>
+        </p:txBody>
+      </p:sp>
+    </p:spTree>
+    <p:extLst>
+      <p:ext uri="{BB962C8B-B14F-4D97-AF65-F5344CB8AC3E}">
+        <p14:creationId xmlns:p14="http://schemas.microsoft.com/office/powerpoint/2010/main" val="3095838342"/>
       </p:ext>
     </p:extLst>
   </p:cSld>
@@ -3434,8 +3932,8 @@
         </p:nvSpPr>
         <p:spPr>
           <a:xfrm>
-            <a:off x="217714" y="255046"/>
-            <a:ext cx="11756571" cy="355354"/>
+            <a:off x="217714" y="189732"/>
+            <a:ext cx="11756571" cy="655436"/>
           </a:xfrm>
           <a:prstGeom prst="rect">
             <a:avLst/>
@@ -3455,21 +3953,96 @@
               <a:buNone/>
             </a:pPr>
             <a:r>
-              <a:rPr kumimoji="0" lang="en-US" altLang="en-US" sz="1300" b="0" i="0" u="none" strike="noStrike" cap="none" normalizeH="0" baseline="0">
-                <a:ln>
-                  <a:noFill/>
-                </a:ln>
-                <a:solidFill>
-                  <a:schemeClr val="tx1"/>
-                </a:solidFill>
-                <a:effectLst/>
+              <a:rPr lang="en-US" altLang="en-US" sz="1300">
                 <a:latin typeface="Arial" panose="020B0604020202020204" pitchFamily="34" charset="0"/>
               </a:rPr>
-              <a:t>.</a:t>
-            </a:r>
-          </a:p>
-        </p:txBody>
-      </p:sp>
+              <a:t>`</a:t>
+            </a:r>
+            <a:r>
+              <a:rPr lang="en-US" altLang="en-US" sz="1300" b="1">
+                <a:latin typeface="Arial" panose="020B0604020202020204" pitchFamily="34" charset="0"/>
+              </a:rPr>
+              <a:t>resources\views\frontend\layouts\master.blade.php</a:t>
+            </a:r>
+            <a:r>
+              <a:rPr lang="en-US" altLang="en-US" sz="1300">
+                <a:latin typeface="Arial" panose="020B0604020202020204" pitchFamily="34" charset="0"/>
+              </a:rPr>
+              <a:t>` </a:t>
+            </a:r>
+            <a:r>
+              <a:rPr lang="az-Latn-AZ" altLang="en-US" sz="1300">
+                <a:latin typeface="Arial" panose="020B0604020202020204" pitchFamily="34" charset="0"/>
+              </a:rPr>
+              <a:t>faylındakı qırmızı ilə işarətlənən hissəni `</a:t>
+            </a:r>
+            <a:r>
+              <a:rPr lang="en-US" altLang="en-US" sz="1300" b="1">
+                <a:latin typeface="Arial" panose="020B0604020202020204" pitchFamily="34" charset="0"/>
+              </a:rPr>
+              <a:t>resources\views\frontend\home\home.blade.php</a:t>
+            </a:r>
+            <a:r>
+              <a:rPr lang="az-Latn-AZ" altLang="en-US" sz="1300">
+                <a:latin typeface="Arial" panose="020B0604020202020204" pitchFamily="34" charset="0"/>
+              </a:rPr>
+              <a:t>` faylına köçürdükdən sonra </a:t>
+            </a:r>
+            <a:r>
+              <a:rPr lang="en-US" altLang="en-US" sz="1300" b="1">
+                <a:latin typeface="Arial" panose="020B0604020202020204" pitchFamily="34" charset="0"/>
+              </a:rPr>
+              <a:t>@yield() </a:t>
+            </a:r>
+            <a:r>
+              <a:rPr lang="az-Latn-AZ" altLang="en-US" sz="1300">
+                <a:latin typeface="Arial" panose="020B0604020202020204" pitchFamily="34" charset="0"/>
+              </a:rPr>
+              <a:t>direktivi ilə çağırırıq.</a:t>
+            </a:r>
+            <a:endParaRPr kumimoji="0" lang="en-US" altLang="en-US" sz="1300" b="0" i="0" u="none" strike="noStrike" cap="none" normalizeH="0" baseline="0">
+              <a:ln>
+                <a:noFill/>
+              </a:ln>
+              <a:solidFill>
+                <a:schemeClr val="tx1"/>
+              </a:solidFill>
+              <a:effectLst/>
+              <a:latin typeface="Arial" panose="020B0604020202020204" pitchFamily="34" charset="0"/>
+            </a:endParaRPr>
+          </a:p>
+        </p:txBody>
+      </p:sp>
+      <p:pic>
+        <p:nvPicPr>
+          <p:cNvPr id="8" name="Picture 7">
+            <a:extLst>
+              <a:ext uri="{FF2B5EF4-FFF2-40B4-BE49-F238E27FC236}">
+                <a16:creationId xmlns:a16="http://schemas.microsoft.com/office/drawing/2014/main" id="{514DC96F-69C7-3EF7-B486-A9AF51C561C7}"/>
+              </a:ext>
+            </a:extLst>
+          </p:cNvPr>
+          <p:cNvPicPr>
+            <a:picLocks noChangeAspect="1"/>
+          </p:cNvPicPr>
+          <p:nvPr/>
+        </p:nvPicPr>
+        <p:blipFill>
+          <a:blip r:embed="rId2"/>
+          <a:stretch>
+            <a:fillRect/>
+          </a:stretch>
+        </p:blipFill>
+        <p:spPr>
+          <a:xfrm>
+            <a:off x="3620056" y="1474236"/>
+            <a:ext cx="8571943" cy="5383763"/>
+          </a:xfrm>
+          <a:prstGeom prst="rect">
+            <a:avLst/>
+          </a:prstGeom>
+        </p:spPr>
+      </p:pic>
     </p:spTree>
     <p:extLst>
       <p:ext uri="{BB962C8B-B14F-4D97-AF65-F5344CB8AC3E}">
@@ -3491,7 +4064,7 @@
         <p:cNvPr id="1" name="">
           <a:extLst>
             <a:ext uri="{FF2B5EF4-FFF2-40B4-BE49-F238E27FC236}">
-              <a16:creationId xmlns:a16="http://schemas.microsoft.com/office/drawing/2014/main" id="{ECE25D7D-A080-F22B-7E8D-36EC827289A1}"/>
+              <a16:creationId xmlns:a16="http://schemas.microsoft.com/office/drawing/2014/main" id="{EBA23456-0D27-39B5-9674-FCD3C578598A}"/>
             </a:ext>
           </a:extLst>
         </p:cNvPr>
@@ -3511,7 +4084,874 @@
           <p:cNvPr id="3" name="TextBox 2">
             <a:extLst>
               <a:ext uri="{FF2B5EF4-FFF2-40B4-BE49-F238E27FC236}">
-                <a16:creationId xmlns:a16="http://schemas.microsoft.com/office/drawing/2014/main" id="{E33F16A3-A6E8-401E-847B-09570DC6E4CB}"/>
+                <a16:creationId xmlns:a16="http://schemas.microsoft.com/office/drawing/2014/main" id="{F69E8959-D83F-DE9D-E78F-E11917181781}"/>
+              </a:ext>
+            </a:extLst>
+          </p:cNvPr>
+          <p:cNvSpPr txBox="1"/>
+          <p:nvPr/>
+        </p:nvSpPr>
+        <p:spPr>
+          <a:xfrm>
+            <a:off x="217714" y="27993"/>
+            <a:ext cx="11756571" cy="355354"/>
+          </a:xfrm>
+          <a:prstGeom prst="rect">
+            <a:avLst/>
+          </a:prstGeom>
+          <a:noFill/>
+        </p:spPr>
+        <p:txBody>
+          <a:bodyPr wrap="square">
+            <a:spAutoFit/>
+          </a:bodyPr>
+          <a:lstStyle/>
+          <a:p>
+            <a:pPr>
+              <a:lnSpc>
+                <a:spcPct val="150000"/>
+              </a:lnSpc>
+              <a:buNone/>
+            </a:pPr>
+            <a:r>
+              <a:rPr lang="az-Latn-AZ" altLang="en-US" sz="1300">
+                <a:latin typeface="Arial" panose="020B0604020202020204" pitchFamily="34" charset="0"/>
+              </a:rPr>
+              <a:t>Şablonu hissələrə ayırırıq.</a:t>
+            </a:r>
+            <a:endParaRPr kumimoji="0" lang="en-US" altLang="en-US" sz="1300" b="0" i="0" u="none" strike="noStrike" cap="none" normalizeH="0" baseline="0">
+              <a:ln>
+                <a:noFill/>
+              </a:ln>
+              <a:solidFill>
+                <a:schemeClr val="tx1"/>
+              </a:solidFill>
+              <a:effectLst/>
+              <a:latin typeface="Arial" panose="020B0604020202020204" pitchFamily="34" charset="0"/>
+            </a:endParaRPr>
+          </a:p>
+        </p:txBody>
+      </p:sp>
+      <p:pic>
+        <p:nvPicPr>
+          <p:cNvPr id="4" name="Picture 3">
+            <a:extLst>
+              <a:ext uri="{FF2B5EF4-FFF2-40B4-BE49-F238E27FC236}">
+                <a16:creationId xmlns:a16="http://schemas.microsoft.com/office/drawing/2014/main" id="{9F582A22-B3D9-8EFB-27DA-DA5C5DAB8354}"/>
+              </a:ext>
+            </a:extLst>
+          </p:cNvPr>
+          <p:cNvPicPr>
+            <a:picLocks noChangeAspect="1"/>
+          </p:cNvPicPr>
+          <p:nvPr/>
+        </p:nvPicPr>
+        <p:blipFill>
+          <a:blip r:embed="rId2"/>
+          <a:stretch>
+            <a:fillRect/>
+          </a:stretch>
+        </p:blipFill>
+        <p:spPr>
+          <a:xfrm>
+            <a:off x="0" y="441158"/>
+            <a:ext cx="12192000" cy="6416842"/>
+          </a:xfrm>
+          <a:prstGeom prst="rect">
+            <a:avLst/>
+          </a:prstGeom>
+        </p:spPr>
+      </p:pic>
+    </p:spTree>
+    <p:extLst>
+      <p:ext uri="{BB962C8B-B14F-4D97-AF65-F5344CB8AC3E}">
+        <p14:creationId xmlns:p14="http://schemas.microsoft.com/office/powerpoint/2010/main" val="3162506982"/>
+      </p:ext>
+    </p:extLst>
+  </p:cSld>
+  <p:clrMapOvr>
+    <a:masterClrMapping/>
+  </p:clrMapOvr>
+</p:sld>
+</file>
+
+<file path=ppt/slides/slide4.xml><?xml version="1.0" encoding="utf-8"?>
+<p:sld xmlns:a="http://schemas.openxmlformats.org/drawingml/2006/main" xmlns:r="http://schemas.openxmlformats.org/officeDocument/2006/relationships" xmlns:p="http://schemas.openxmlformats.org/presentationml/2006/main">
+  <p:cSld>
+    <p:spTree>
+      <p:nvGrpSpPr>
+        <p:cNvPr id="1" name="">
+          <a:extLst>
+            <a:ext uri="{FF2B5EF4-FFF2-40B4-BE49-F238E27FC236}">
+              <a16:creationId xmlns:a16="http://schemas.microsoft.com/office/drawing/2014/main" id="{132F14AB-FAA2-91A6-CD13-498323F0F6D5}"/>
+            </a:ext>
+          </a:extLst>
+        </p:cNvPr>
+        <p:cNvGrpSpPr/>
+        <p:nvPr/>
+      </p:nvGrpSpPr>
+      <p:grpSpPr>
+        <a:xfrm>
+          <a:off x="0" y="0"/>
+          <a:ext cx="0" cy="0"/>
+          <a:chOff x="0" y="0"/>
+          <a:chExt cx="0" cy="0"/>
+        </a:xfrm>
+      </p:grpSpPr>
+      <p:sp>
+        <p:nvSpPr>
+          <p:cNvPr id="3" name="TextBox 2">
+            <a:extLst>
+              <a:ext uri="{FF2B5EF4-FFF2-40B4-BE49-F238E27FC236}">
+                <a16:creationId xmlns:a16="http://schemas.microsoft.com/office/drawing/2014/main" id="{128607EB-D4CA-0E81-808A-FAB2450E3343}"/>
+              </a:ext>
+            </a:extLst>
+          </p:cNvPr>
+          <p:cNvSpPr txBox="1"/>
+          <p:nvPr/>
+        </p:nvSpPr>
+        <p:spPr>
+          <a:xfrm>
+            <a:off x="217713" y="161740"/>
+            <a:ext cx="11756571" cy="355354"/>
+          </a:xfrm>
+          <a:prstGeom prst="rect">
+            <a:avLst/>
+          </a:prstGeom>
+          <a:noFill/>
+        </p:spPr>
+        <p:txBody>
+          <a:bodyPr wrap="square">
+            <a:spAutoFit/>
+          </a:bodyPr>
+          <a:lstStyle/>
+          <a:p>
+            <a:pPr>
+              <a:lnSpc>
+                <a:spcPct val="150000"/>
+              </a:lnSpc>
+              <a:buNone/>
+            </a:pPr>
+            <a:r>
+              <a:rPr lang="az-Latn-AZ" altLang="en-US" sz="1300">
+                <a:latin typeface="Arial" panose="020B0604020202020204" pitchFamily="34" charset="0"/>
+              </a:rPr>
+              <a:t>`</a:t>
+            </a:r>
+            <a:r>
+              <a:rPr lang="en-US" altLang="en-US" sz="1300" b="1">
+                <a:latin typeface="Arial" panose="020B0604020202020204" pitchFamily="34" charset="0"/>
+              </a:rPr>
+              <a:t>resources\views\frontend\home\home.blade.php</a:t>
+            </a:r>
+            <a:r>
+              <a:rPr lang="az-Latn-AZ" altLang="en-US" sz="1300">
+                <a:latin typeface="Arial" panose="020B0604020202020204" pitchFamily="34" charset="0"/>
+              </a:rPr>
+              <a:t>` faylındakı </a:t>
+            </a:r>
+            <a:r>
+              <a:rPr lang="az-Latn-AZ" altLang="en-US" sz="1300" b="1">
+                <a:latin typeface="Arial" panose="020B0604020202020204" pitchFamily="34" charset="0"/>
+              </a:rPr>
+              <a:t>SECTİON</a:t>
+            </a:r>
+            <a:r>
+              <a:rPr lang="az-Latn-AZ" altLang="en-US" sz="1300">
+                <a:latin typeface="Arial" panose="020B0604020202020204" pitchFamily="34" charset="0"/>
+              </a:rPr>
+              <a:t> -lar üçün isə ayrıca fayl yaradırıq.</a:t>
+            </a:r>
+            <a:r>
+              <a:rPr lang="en-US" altLang="en-US" sz="1300">
+                <a:latin typeface="Arial" panose="020B0604020202020204" pitchFamily="34" charset="0"/>
+              </a:rPr>
+              <a:t> </a:t>
+            </a:r>
+            <a:r>
+              <a:rPr lang="az-Latn-AZ" altLang="en-US" sz="1300">
+                <a:latin typeface="Arial" panose="020B0604020202020204" pitchFamily="34" charset="0"/>
+              </a:rPr>
+              <a:t>Ardı var...</a:t>
+            </a:r>
+            <a:endParaRPr kumimoji="0" lang="en-US" altLang="en-US" sz="1300" b="0" i="0" u="none" strike="noStrike" cap="none" normalizeH="0" baseline="0">
+              <a:ln>
+                <a:noFill/>
+              </a:ln>
+              <a:solidFill>
+                <a:schemeClr val="tx1"/>
+              </a:solidFill>
+              <a:effectLst/>
+              <a:latin typeface="Arial" panose="020B0604020202020204" pitchFamily="34" charset="0"/>
+            </a:endParaRPr>
+          </a:p>
+        </p:txBody>
+      </p:sp>
+      <p:grpSp>
+        <p:nvGrpSpPr>
+          <p:cNvPr id="14" name="Group 13">
+            <a:extLst>
+              <a:ext uri="{FF2B5EF4-FFF2-40B4-BE49-F238E27FC236}">
+                <a16:creationId xmlns:a16="http://schemas.microsoft.com/office/drawing/2014/main" id="{3885CA87-5728-721C-EC82-9FEAC46CB42A}"/>
+              </a:ext>
+            </a:extLst>
+          </p:cNvPr>
+          <p:cNvGrpSpPr/>
+          <p:nvPr/>
+        </p:nvGrpSpPr>
+        <p:grpSpPr>
+          <a:xfrm>
+            <a:off x="0" y="745796"/>
+            <a:ext cx="12192000" cy="6112204"/>
+            <a:chOff x="0" y="745796"/>
+            <a:chExt cx="12192000" cy="6112204"/>
+          </a:xfrm>
+        </p:grpSpPr>
+        <p:pic>
+          <p:nvPicPr>
+            <p:cNvPr id="5" name="Picture 4">
+              <a:extLst>
+                <a:ext uri="{FF2B5EF4-FFF2-40B4-BE49-F238E27FC236}">
+                  <a16:creationId xmlns:a16="http://schemas.microsoft.com/office/drawing/2014/main" id="{0CE495FD-3A52-5A7B-E3A2-21EDC096125C}"/>
+                </a:ext>
+              </a:extLst>
+            </p:cNvPr>
+            <p:cNvPicPr>
+              <a:picLocks noChangeAspect="1"/>
+            </p:cNvPicPr>
+            <p:nvPr/>
+          </p:nvPicPr>
+          <p:blipFill>
+            <a:blip r:embed="rId2"/>
+            <a:stretch>
+              <a:fillRect/>
+            </a:stretch>
+          </p:blipFill>
+          <p:spPr>
+            <a:xfrm>
+              <a:off x="0" y="745796"/>
+              <a:ext cx="12192000" cy="6112204"/>
+            </a:xfrm>
+            <a:prstGeom prst="rect">
+              <a:avLst/>
+            </a:prstGeom>
+          </p:spPr>
+        </p:pic>
+        <p:grpSp>
+          <p:nvGrpSpPr>
+            <p:cNvPr id="13" name="Group 12">
+              <a:extLst>
+                <a:ext uri="{FF2B5EF4-FFF2-40B4-BE49-F238E27FC236}">
+                  <a16:creationId xmlns:a16="http://schemas.microsoft.com/office/drawing/2014/main" id="{82BB0B49-68A9-360B-3FED-C3A024E47C58}"/>
+                </a:ext>
+              </a:extLst>
+            </p:cNvPr>
+            <p:cNvGrpSpPr/>
+            <p:nvPr/>
+          </p:nvGrpSpPr>
+          <p:grpSpPr>
+            <a:xfrm>
+              <a:off x="4209179" y="1220870"/>
+              <a:ext cx="5541480" cy="3147840"/>
+              <a:chOff x="4209179" y="1220870"/>
+              <a:chExt cx="5541480" cy="3147840"/>
+            </a:xfrm>
+          </p:grpSpPr>
+          <mc:AlternateContent xmlns:mc="http://schemas.openxmlformats.org/markup-compatibility/2006">
+            <mc:Choice xmlns:p14="http://schemas.microsoft.com/office/powerpoint/2010/main" Requires="p14">
+              <p:contentPart p14:bwMode="auto" r:id="rId3">
+                <p14:nvContentPartPr>
+                  <p14:cNvPr id="6" name="Ink 5">
+                    <a:extLst>
+                      <a:ext uri="{FF2B5EF4-FFF2-40B4-BE49-F238E27FC236}">
+                        <a16:creationId xmlns:a16="http://schemas.microsoft.com/office/drawing/2014/main" id="{7B544C7C-20B4-B4E2-5794-AFFBB5472C17}"/>
+                      </a:ext>
+                    </a:extLst>
+                  </p14:cNvPr>
+                  <p14:cNvContentPartPr/>
+                  <p14:nvPr/>
+                </p14:nvContentPartPr>
+                <p14:xfrm>
+                  <a:off x="4344539" y="1220870"/>
+                  <a:ext cx="722520" cy="1161000"/>
+                </p14:xfrm>
+              </p:contentPart>
+            </mc:Choice>
+            <mc:Fallback>
+              <p:pic>
+                <p:nvPicPr>
+                  <p:cNvPr id="6" name="Ink 5">
+                    <a:extLst>
+                      <a:ext uri="{FF2B5EF4-FFF2-40B4-BE49-F238E27FC236}">
+                        <a16:creationId xmlns:a16="http://schemas.microsoft.com/office/drawing/2014/main" id="{7B544C7C-20B4-B4E2-5794-AFFBB5472C17}"/>
+                      </a:ext>
+                    </a:extLst>
+                  </p:cNvPr>
+                  <p:cNvPicPr/>
+                  <p:nvPr/>
+                </p:nvPicPr>
+                <p:blipFill>
+                  <a:blip r:embed="rId4"/>
+                  <a:stretch>
+                    <a:fillRect/>
+                  </a:stretch>
+                </p:blipFill>
+                <p:spPr>
+                  <a:xfrm>
+                    <a:off x="4338419" y="1214750"/>
+                    <a:ext cx="734760" cy="1173240"/>
+                  </a:xfrm>
+                  <a:prstGeom prst="rect">
+                    <a:avLst/>
+                  </a:prstGeom>
+                </p:spPr>
+              </p:pic>
+            </mc:Fallback>
+          </mc:AlternateContent>
+          <mc:AlternateContent xmlns:mc="http://schemas.openxmlformats.org/markup-compatibility/2006">
+            <mc:Choice xmlns:p14="http://schemas.microsoft.com/office/powerpoint/2010/main" Requires="p14">
+              <p:contentPart p14:bwMode="auto" r:id="rId5">
+                <p14:nvContentPartPr>
+                  <p14:cNvPr id="7" name="Ink 6">
+                    <a:extLst>
+                      <a:ext uri="{FF2B5EF4-FFF2-40B4-BE49-F238E27FC236}">
+                        <a16:creationId xmlns:a16="http://schemas.microsoft.com/office/drawing/2014/main" id="{9644E44D-8F6D-6C81-973B-719D2AB85846}"/>
+                      </a:ext>
+                    </a:extLst>
+                  </p14:cNvPr>
+                  <p14:cNvContentPartPr/>
+                  <p14:nvPr/>
+                </p14:nvContentPartPr>
+                <p14:xfrm>
+                  <a:off x="4302059" y="2313830"/>
+                  <a:ext cx="101160" cy="133200"/>
+                </p14:xfrm>
+              </p:contentPart>
+            </mc:Choice>
+            <mc:Fallback>
+              <p:pic>
+                <p:nvPicPr>
+                  <p:cNvPr id="7" name="Ink 6">
+                    <a:extLst>
+                      <a:ext uri="{FF2B5EF4-FFF2-40B4-BE49-F238E27FC236}">
+                        <a16:creationId xmlns:a16="http://schemas.microsoft.com/office/drawing/2014/main" id="{9644E44D-8F6D-6C81-973B-719D2AB85846}"/>
+                      </a:ext>
+                    </a:extLst>
+                  </p:cNvPr>
+                  <p:cNvPicPr/>
+                  <p:nvPr/>
+                </p:nvPicPr>
+                <p:blipFill>
+                  <a:blip r:embed="rId6"/>
+                  <a:stretch>
+                    <a:fillRect/>
+                  </a:stretch>
+                </p:blipFill>
+                <p:spPr>
+                  <a:xfrm>
+                    <a:off x="4295939" y="2307710"/>
+                    <a:ext cx="113400" cy="145440"/>
+                  </a:xfrm>
+                  <a:prstGeom prst="rect">
+                    <a:avLst/>
+                  </a:prstGeom>
+                </p:spPr>
+              </p:pic>
+            </mc:Fallback>
+          </mc:AlternateContent>
+          <mc:AlternateContent xmlns:mc="http://schemas.openxmlformats.org/markup-compatibility/2006">
+            <mc:Choice xmlns:p14="http://schemas.microsoft.com/office/powerpoint/2010/main" Requires="p14">
+              <p:contentPart p14:bwMode="auto" r:id="rId7">
+                <p14:nvContentPartPr>
+                  <p14:cNvPr id="9" name="Ink 8">
+                    <a:extLst>
+                      <a:ext uri="{FF2B5EF4-FFF2-40B4-BE49-F238E27FC236}">
+                        <a16:creationId xmlns:a16="http://schemas.microsoft.com/office/drawing/2014/main" id="{9CED43F2-C60F-31EF-26EA-7352BF159664}"/>
+                      </a:ext>
+                    </a:extLst>
+                  </p14:cNvPr>
+                  <p14:cNvContentPartPr/>
+                  <p14:nvPr/>
+                </p14:nvContentPartPr>
+                <p14:xfrm>
+                  <a:off x="4294499" y="1287470"/>
+                  <a:ext cx="2256120" cy="2008800"/>
+                </p14:xfrm>
+              </p:contentPart>
+            </mc:Choice>
+            <mc:Fallback>
+              <p:pic>
+                <p:nvPicPr>
+                  <p:cNvPr id="9" name="Ink 8">
+                    <a:extLst>
+                      <a:ext uri="{FF2B5EF4-FFF2-40B4-BE49-F238E27FC236}">
+                        <a16:creationId xmlns:a16="http://schemas.microsoft.com/office/drawing/2014/main" id="{9CED43F2-C60F-31EF-26EA-7352BF159664}"/>
+                      </a:ext>
+                    </a:extLst>
+                  </p:cNvPr>
+                  <p:cNvPicPr/>
+                  <p:nvPr/>
+                </p:nvPicPr>
+                <p:blipFill>
+                  <a:blip r:embed="rId8"/>
+                  <a:stretch>
+                    <a:fillRect/>
+                  </a:stretch>
+                </p:blipFill>
+                <p:spPr>
+                  <a:xfrm>
+                    <a:off x="4288379" y="1281350"/>
+                    <a:ext cx="2268360" cy="2021040"/>
+                  </a:xfrm>
+                  <a:prstGeom prst="rect">
+                    <a:avLst/>
+                  </a:prstGeom>
+                </p:spPr>
+              </p:pic>
+            </mc:Fallback>
+          </mc:AlternateContent>
+          <mc:AlternateContent xmlns:mc="http://schemas.openxmlformats.org/markup-compatibility/2006">
+            <mc:Choice xmlns:p14="http://schemas.microsoft.com/office/powerpoint/2010/main" Requires="p14">
+              <p:contentPart p14:bwMode="auto" r:id="rId9">
+                <p14:nvContentPartPr>
+                  <p14:cNvPr id="10" name="Ink 9">
+                    <a:extLst>
+                      <a:ext uri="{FF2B5EF4-FFF2-40B4-BE49-F238E27FC236}">
+                        <a16:creationId xmlns:a16="http://schemas.microsoft.com/office/drawing/2014/main" id="{9EE2E2BA-4A73-22C5-C456-F99E852EFB90}"/>
+                      </a:ext>
+                    </a:extLst>
+                  </p14:cNvPr>
+                  <p14:cNvContentPartPr/>
+                  <p14:nvPr/>
+                </p14:nvContentPartPr>
+                <p14:xfrm>
+                  <a:off x="4209179" y="3162710"/>
+                  <a:ext cx="174240" cy="209880"/>
+                </p14:xfrm>
+              </p:contentPart>
+            </mc:Choice>
+            <mc:Fallback>
+              <p:pic>
+                <p:nvPicPr>
+                  <p:cNvPr id="10" name="Ink 9">
+                    <a:extLst>
+                      <a:ext uri="{FF2B5EF4-FFF2-40B4-BE49-F238E27FC236}">
+                        <a16:creationId xmlns:a16="http://schemas.microsoft.com/office/drawing/2014/main" id="{9EE2E2BA-4A73-22C5-C456-F99E852EFB90}"/>
+                      </a:ext>
+                    </a:extLst>
+                  </p:cNvPr>
+                  <p:cNvPicPr/>
+                  <p:nvPr/>
+                </p:nvPicPr>
+                <p:blipFill>
+                  <a:blip r:embed="rId10"/>
+                  <a:stretch>
+                    <a:fillRect/>
+                  </a:stretch>
+                </p:blipFill>
+                <p:spPr>
+                  <a:xfrm>
+                    <a:off x="4203059" y="3156590"/>
+                    <a:ext cx="186480" cy="222120"/>
+                  </a:xfrm>
+                  <a:prstGeom prst="rect">
+                    <a:avLst/>
+                  </a:prstGeom>
+                </p:spPr>
+              </p:pic>
+            </mc:Fallback>
+          </mc:AlternateContent>
+          <mc:AlternateContent xmlns:mc="http://schemas.openxmlformats.org/markup-compatibility/2006">
+            <mc:Choice xmlns:p14="http://schemas.microsoft.com/office/powerpoint/2010/main" Requires="p14">
+              <p:contentPart p14:bwMode="auto" r:id="rId11">
+                <p14:nvContentPartPr>
+                  <p14:cNvPr id="11" name="Ink 10">
+                    <a:extLst>
+                      <a:ext uri="{FF2B5EF4-FFF2-40B4-BE49-F238E27FC236}">
+                        <a16:creationId xmlns:a16="http://schemas.microsoft.com/office/drawing/2014/main" id="{95DC141C-B4A3-296B-E110-0621F7A3BEE6}"/>
+                      </a:ext>
+                    </a:extLst>
+                  </p14:cNvPr>
+                  <p14:cNvContentPartPr/>
+                  <p14:nvPr/>
+                </p14:nvContentPartPr>
+                <p14:xfrm>
+                  <a:off x="4703459" y="1296830"/>
+                  <a:ext cx="5047200" cy="2982960"/>
+                </p14:xfrm>
+              </p:contentPart>
+            </mc:Choice>
+            <mc:Fallback>
+              <p:pic>
+                <p:nvPicPr>
+                  <p:cNvPr id="11" name="Ink 10">
+                    <a:extLst>
+                      <a:ext uri="{FF2B5EF4-FFF2-40B4-BE49-F238E27FC236}">
+                        <a16:creationId xmlns:a16="http://schemas.microsoft.com/office/drawing/2014/main" id="{95DC141C-B4A3-296B-E110-0621F7A3BEE6}"/>
+                      </a:ext>
+                    </a:extLst>
+                  </p:cNvPr>
+                  <p:cNvPicPr/>
+                  <p:nvPr/>
+                </p:nvPicPr>
+                <p:blipFill>
+                  <a:blip r:embed="rId12"/>
+                  <a:stretch>
+                    <a:fillRect/>
+                  </a:stretch>
+                </p:blipFill>
+                <p:spPr>
+                  <a:xfrm>
+                    <a:off x="4697339" y="1290710"/>
+                    <a:ext cx="5059440" cy="2995200"/>
+                  </a:xfrm>
+                  <a:prstGeom prst="rect">
+                    <a:avLst/>
+                  </a:prstGeom>
+                </p:spPr>
+              </p:pic>
+            </mc:Fallback>
+          </mc:AlternateContent>
+          <mc:AlternateContent xmlns:mc="http://schemas.openxmlformats.org/markup-compatibility/2006">
+            <mc:Choice xmlns:p14="http://schemas.microsoft.com/office/powerpoint/2010/main" Requires="p14">
+              <p:contentPart p14:bwMode="auto" r:id="rId13">
+                <p14:nvContentPartPr>
+                  <p14:cNvPr id="12" name="Ink 11">
+                    <a:extLst>
+                      <a:ext uri="{FF2B5EF4-FFF2-40B4-BE49-F238E27FC236}">
+                        <a16:creationId xmlns:a16="http://schemas.microsoft.com/office/drawing/2014/main" id="{8522C625-07C9-CD57-3ED3-D8D6C4EFDE25}"/>
+                      </a:ext>
+                    </a:extLst>
+                  </p14:cNvPr>
+                  <p14:cNvContentPartPr/>
+                  <p14:nvPr/>
+                </p14:nvContentPartPr>
+                <p14:xfrm>
+                  <a:off x="4580699" y="4208150"/>
+                  <a:ext cx="171360" cy="160560"/>
+                </p14:xfrm>
+              </p:contentPart>
+            </mc:Choice>
+            <mc:Fallback>
+              <p:pic>
+                <p:nvPicPr>
+                  <p:cNvPr id="12" name="Ink 11">
+                    <a:extLst>
+                      <a:ext uri="{FF2B5EF4-FFF2-40B4-BE49-F238E27FC236}">
+                        <a16:creationId xmlns:a16="http://schemas.microsoft.com/office/drawing/2014/main" id="{8522C625-07C9-CD57-3ED3-D8D6C4EFDE25}"/>
+                      </a:ext>
+                    </a:extLst>
+                  </p:cNvPr>
+                  <p:cNvPicPr/>
+                  <p:nvPr/>
+                </p:nvPicPr>
+                <p:blipFill>
+                  <a:blip r:embed="rId14"/>
+                  <a:stretch>
+                    <a:fillRect/>
+                  </a:stretch>
+                </p:blipFill>
+                <p:spPr>
+                  <a:xfrm>
+                    <a:off x="4574579" y="4202030"/>
+                    <a:ext cx="183600" cy="172800"/>
+                  </a:xfrm>
+                  <a:prstGeom prst="rect">
+                    <a:avLst/>
+                  </a:prstGeom>
+                </p:spPr>
+              </p:pic>
+            </mc:Fallback>
+          </mc:AlternateContent>
+        </p:grpSp>
+      </p:grpSp>
+    </p:spTree>
+    <p:extLst>
+      <p:ext uri="{BB962C8B-B14F-4D97-AF65-F5344CB8AC3E}">
+        <p14:creationId xmlns:p14="http://schemas.microsoft.com/office/powerpoint/2010/main" val="3501518907"/>
+      </p:ext>
+    </p:extLst>
+  </p:cSld>
+  <p:clrMapOvr>
+    <a:masterClrMapping/>
+  </p:clrMapOvr>
+</p:sld>
+</file>
+
+<file path=ppt/slides/slide5.xml><?xml version="1.0" encoding="utf-8"?>
+<p:sld xmlns:a="http://schemas.openxmlformats.org/drawingml/2006/main" xmlns:r="http://schemas.openxmlformats.org/officeDocument/2006/relationships" xmlns:p="http://schemas.openxmlformats.org/presentationml/2006/main">
+  <p:cSld>
+    <p:spTree>
+      <p:nvGrpSpPr>
+        <p:cNvPr id="1" name="">
+          <a:extLst>
+            <a:ext uri="{FF2B5EF4-FFF2-40B4-BE49-F238E27FC236}">
+              <a16:creationId xmlns:a16="http://schemas.microsoft.com/office/drawing/2014/main" id="{21BF42B7-30B4-1308-DD90-4586E69B57E2}"/>
+            </a:ext>
+          </a:extLst>
+        </p:cNvPr>
+        <p:cNvGrpSpPr/>
+        <p:nvPr/>
+      </p:nvGrpSpPr>
+      <p:grpSpPr>
+        <a:xfrm>
+          <a:off x="0" y="0"/>
+          <a:ext cx="0" cy="0"/>
+          <a:chOff x="0" y="0"/>
+          <a:chExt cx="0" cy="0"/>
+        </a:xfrm>
+      </p:grpSpPr>
+      <p:sp>
+        <p:nvSpPr>
+          <p:cNvPr id="3" name="TextBox 2">
+            <a:extLst>
+              <a:ext uri="{FF2B5EF4-FFF2-40B4-BE49-F238E27FC236}">
+                <a16:creationId xmlns:a16="http://schemas.microsoft.com/office/drawing/2014/main" id="{95385904-CF39-E65D-6479-D5318240B688}"/>
+              </a:ext>
+            </a:extLst>
+          </p:cNvPr>
+          <p:cNvSpPr txBox="1"/>
+          <p:nvPr/>
+        </p:nvSpPr>
+        <p:spPr>
+          <a:xfrm>
+            <a:off x="217713" y="105756"/>
+            <a:ext cx="11756571" cy="355354"/>
+          </a:xfrm>
+          <a:prstGeom prst="rect">
+            <a:avLst/>
+          </a:prstGeom>
+          <a:noFill/>
+        </p:spPr>
+        <p:txBody>
+          <a:bodyPr wrap="square">
+            <a:spAutoFit/>
+          </a:bodyPr>
+          <a:lstStyle/>
+          <a:p>
+            <a:pPr>
+              <a:lnSpc>
+                <a:spcPct val="150000"/>
+              </a:lnSpc>
+              <a:buNone/>
+            </a:pPr>
+            <a:r>
+              <a:rPr lang="az-Latn-AZ" altLang="en-US" sz="1300">
+                <a:latin typeface="Arial" panose="020B0604020202020204" pitchFamily="34" charset="0"/>
+              </a:rPr>
+              <a:t>Ardı var...</a:t>
+            </a:r>
+            <a:endParaRPr kumimoji="0" lang="en-US" altLang="en-US" sz="1300" b="0" i="0" u="none" strike="noStrike" cap="none" normalizeH="0" baseline="0">
+              <a:ln>
+                <a:noFill/>
+              </a:ln>
+              <a:solidFill>
+                <a:schemeClr val="tx1"/>
+              </a:solidFill>
+              <a:effectLst/>
+              <a:latin typeface="Arial" panose="020B0604020202020204" pitchFamily="34" charset="0"/>
+            </a:endParaRPr>
+          </a:p>
+        </p:txBody>
+      </p:sp>
+      <p:pic>
+        <p:nvPicPr>
+          <p:cNvPr id="6" name="Picture 5">
+            <a:extLst>
+              <a:ext uri="{FF2B5EF4-FFF2-40B4-BE49-F238E27FC236}">
+                <a16:creationId xmlns:a16="http://schemas.microsoft.com/office/drawing/2014/main" id="{58078581-FED2-0667-8576-2A46A4F62CF1}"/>
+              </a:ext>
+            </a:extLst>
+          </p:cNvPr>
+          <p:cNvPicPr>
+            <a:picLocks noChangeAspect="1"/>
+          </p:cNvPicPr>
+          <p:nvPr/>
+        </p:nvPicPr>
+        <p:blipFill>
+          <a:blip r:embed="rId2"/>
+          <a:stretch>
+            <a:fillRect/>
+          </a:stretch>
+        </p:blipFill>
+        <p:spPr>
+          <a:xfrm>
+            <a:off x="-1" y="579446"/>
+            <a:ext cx="12192000" cy="6278554"/>
+          </a:xfrm>
+          <a:prstGeom prst="rect">
+            <a:avLst/>
+          </a:prstGeom>
+        </p:spPr>
+      </p:pic>
+    </p:spTree>
+    <p:extLst>
+      <p:ext uri="{BB962C8B-B14F-4D97-AF65-F5344CB8AC3E}">
+        <p14:creationId xmlns:p14="http://schemas.microsoft.com/office/powerpoint/2010/main" val="2030634268"/>
+      </p:ext>
+    </p:extLst>
+  </p:cSld>
+  <p:clrMapOvr>
+    <a:masterClrMapping/>
+  </p:clrMapOvr>
+</p:sld>
+</file>
+
+<file path=ppt/slides/slide6.xml><?xml version="1.0" encoding="utf-8"?>
+<p:sld xmlns:a="http://schemas.openxmlformats.org/drawingml/2006/main" xmlns:r="http://schemas.openxmlformats.org/officeDocument/2006/relationships" xmlns:p="http://schemas.openxmlformats.org/presentationml/2006/main">
+  <p:cSld>
+    <p:spTree>
+      <p:nvGrpSpPr>
+        <p:cNvPr id="1" name="">
+          <a:extLst>
+            <a:ext uri="{FF2B5EF4-FFF2-40B4-BE49-F238E27FC236}">
+              <a16:creationId xmlns:a16="http://schemas.microsoft.com/office/drawing/2014/main" id="{180F34C2-AED6-DD13-13B7-AE930871A3D4}"/>
+            </a:ext>
+          </a:extLst>
+        </p:cNvPr>
+        <p:cNvGrpSpPr/>
+        <p:nvPr/>
+      </p:nvGrpSpPr>
+      <p:grpSpPr>
+        <a:xfrm>
+          <a:off x="0" y="0"/>
+          <a:ext cx="0" cy="0"/>
+          <a:chOff x="0" y="0"/>
+          <a:chExt cx="0" cy="0"/>
+        </a:xfrm>
+      </p:grpSpPr>
+      <p:sp>
+        <p:nvSpPr>
+          <p:cNvPr id="3" name="TextBox 2">
+            <a:extLst>
+              <a:ext uri="{FF2B5EF4-FFF2-40B4-BE49-F238E27FC236}">
+                <a16:creationId xmlns:a16="http://schemas.microsoft.com/office/drawing/2014/main" id="{8E5FDD46-D635-D1C6-ABFA-44518DC03EE4}"/>
+              </a:ext>
+            </a:extLst>
+          </p:cNvPr>
+          <p:cNvSpPr txBox="1"/>
+          <p:nvPr/>
+        </p:nvSpPr>
+        <p:spPr>
+          <a:xfrm>
+            <a:off x="217713" y="105756"/>
+            <a:ext cx="11756571" cy="355354"/>
+          </a:xfrm>
+          <a:prstGeom prst="rect">
+            <a:avLst/>
+          </a:prstGeom>
+          <a:noFill/>
+        </p:spPr>
+        <p:txBody>
+          <a:bodyPr wrap="square">
+            <a:spAutoFit/>
+          </a:bodyPr>
+          <a:lstStyle/>
+          <a:p>
+            <a:pPr>
+              <a:lnSpc>
+                <a:spcPct val="150000"/>
+              </a:lnSpc>
+              <a:buNone/>
+            </a:pPr>
+            <a:r>
+              <a:rPr kumimoji="0" lang="az-Latn-AZ" altLang="en-US" sz="1300" b="0" i="0" u="none" strike="noStrike" cap="none" normalizeH="0" baseline="0">
+                <a:ln>
+                  <a:noFill/>
+                </a:ln>
+                <a:solidFill>
+                  <a:schemeClr val="tx1"/>
+                </a:solidFill>
+                <a:effectLst/>
+                <a:latin typeface="Arial" panose="020B0604020202020204" pitchFamily="34" charset="0"/>
+              </a:rPr>
+              <a:t>Səhifələrin bölgüsü hələlik bu qədər.</a:t>
+            </a:r>
+            <a:endParaRPr kumimoji="0" lang="en-US" altLang="en-US" sz="1300" b="0" i="0" u="none" strike="noStrike" cap="none" normalizeH="0" baseline="0">
+              <a:ln>
+                <a:noFill/>
+              </a:ln>
+              <a:solidFill>
+                <a:schemeClr val="tx1"/>
+              </a:solidFill>
+              <a:effectLst/>
+              <a:latin typeface="Arial" panose="020B0604020202020204" pitchFamily="34" charset="0"/>
+            </a:endParaRPr>
+          </a:p>
+        </p:txBody>
+      </p:sp>
+      <p:pic>
+        <p:nvPicPr>
+          <p:cNvPr id="4" name="Picture 3">
+            <a:extLst>
+              <a:ext uri="{FF2B5EF4-FFF2-40B4-BE49-F238E27FC236}">
+                <a16:creationId xmlns:a16="http://schemas.microsoft.com/office/drawing/2014/main" id="{D88122C5-6166-F310-C966-361FED3D839E}"/>
+              </a:ext>
+            </a:extLst>
+          </p:cNvPr>
+          <p:cNvPicPr>
+            <a:picLocks noChangeAspect="1"/>
+          </p:cNvPicPr>
+          <p:nvPr/>
+        </p:nvPicPr>
+        <p:blipFill>
+          <a:blip r:embed="rId2"/>
+          <a:stretch>
+            <a:fillRect/>
+          </a:stretch>
+        </p:blipFill>
+        <p:spPr>
+          <a:xfrm>
+            <a:off x="-1" y="531411"/>
+            <a:ext cx="12192000" cy="6326589"/>
+          </a:xfrm>
+          <a:prstGeom prst="rect">
+            <a:avLst/>
+          </a:prstGeom>
+        </p:spPr>
+      </p:pic>
+    </p:spTree>
+    <p:extLst>
+      <p:ext uri="{BB962C8B-B14F-4D97-AF65-F5344CB8AC3E}">
+        <p14:creationId xmlns:p14="http://schemas.microsoft.com/office/powerpoint/2010/main" val="2057428391"/>
+      </p:ext>
+    </p:extLst>
+  </p:cSld>
+  <p:clrMapOvr>
+    <a:masterClrMapping/>
+  </p:clrMapOvr>
+</p:sld>
+</file>
+
+<file path=ppt/slides/slide7.xml><?xml version="1.0" encoding="utf-8"?>
+<p:sld xmlns:a="http://schemas.openxmlformats.org/drawingml/2006/main" xmlns:r="http://schemas.openxmlformats.org/officeDocument/2006/relationships" xmlns:p="http://schemas.openxmlformats.org/presentationml/2006/main">
+  <p:cSld>
+    <p:spTree>
+      <p:nvGrpSpPr>
+        <p:cNvPr id="1" name="">
+          <a:extLst>
+            <a:ext uri="{FF2B5EF4-FFF2-40B4-BE49-F238E27FC236}">
+              <a16:creationId xmlns:a16="http://schemas.microsoft.com/office/drawing/2014/main" id="{CD2B2CB6-87E1-DB72-F274-984FC65020CB}"/>
+            </a:ext>
+          </a:extLst>
+        </p:cNvPr>
+        <p:cNvGrpSpPr/>
+        <p:nvPr/>
+      </p:nvGrpSpPr>
+      <p:grpSpPr>
+        <a:xfrm>
+          <a:off x="0" y="0"/>
+          <a:ext cx="0" cy="0"/>
+          <a:chOff x="0" y="0"/>
+          <a:chExt cx="0" cy="0"/>
+        </a:xfrm>
+      </p:grpSpPr>
+      <p:sp>
+        <p:nvSpPr>
+          <p:cNvPr id="3" name="TextBox 2">
+            <a:extLst>
+              <a:ext uri="{FF2B5EF4-FFF2-40B4-BE49-F238E27FC236}">
+                <a16:creationId xmlns:a16="http://schemas.microsoft.com/office/drawing/2014/main" id="{C979D9F6-1772-3D9C-25E9-57C636723C67}"/>
               </a:ext>
             </a:extLst>
           </p:cNvPr>
@@ -3559,7 +4999,179 @@
     </p:spTree>
     <p:extLst>
       <p:ext uri="{BB962C8B-B14F-4D97-AF65-F5344CB8AC3E}">
-        <p14:creationId xmlns:p14="http://schemas.microsoft.com/office/powerpoint/2010/main" val="3095838342"/>
+        <p14:creationId xmlns:p14="http://schemas.microsoft.com/office/powerpoint/2010/main" val="845785400"/>
+      </p:ext>
+    </p:extLst>
+  </p:cSld>
+  <p:clrMapOvr>
+    <a:masterClrMapping/>
+  </p:clrMapOvr>
+</p:sld>
+</file>
+
+<file path=ppt/slides/slide8.xml><?xml version="1.0" encoding="utf-8"?>
+<p:sld xmlns:a="http://schemas.openxmlformats.org/drawingml/2006/main" xmlns:r="http://schemas.openxmlformats.org/officeDocument/2006/relationships" xmlns:p="http://schemas.openxmlformats.org/presentationml/2006/main">
+  <p:cSld>
+    <p:spTree>
+      <p:nvGrpSpPr>
+        <p:cNvPr id="1" name="">
+          <a:extLst>
+            <a:ext uri="{FF2B5EF4-FFF2-40B4-BE49-F238E27FC236}">
+              <a16:creationId xmlns:a16="http://schemas.microsoft.com/office/drawing/2014/main" id="{C8BE82F0-4E71-08A2-02B5-8B4BC4703ECB}"/>
+            </a:ext>
+          </a:extLst>
+        </p:cNvPr>
+        <p:cNvGrpSpPr/>
+        <p:nvPr/>
+      </p:nvGrpSpPr>
+      <p:grpSpPr>
+        <a:xfrm>
+          <a:off x="0" y="0"/>
+          <a:ext cx="0" cy="0"/>
+          <a:chOff x="0" y="0"/>
+          <a:chExt cx="0" cy="0"/>
+        </a:xfrm>
+      </p:grpSpPr>
+      <p:sp>
+        <p:nvSpPr>
+          <p:cNvPr id="3" name="TextBox 2">
+            <a:extLst>
+              <a:ext uri="{FF2B5EF4-FFF2-40B4-BE49-F238E27FC236}">
+                <a16:creationId xmlns:a16="http://schemas.microsoft.com/office/drawing/2014/main" id="{DD40EBA8-C634-DEA0-3D05-355870BFC1D4}"/>
+              </a:ext>
+            </a:extLst>
+          </p:cNvPr>
+          <p:cNvSpPr txBox="1"/>
+          <p:nvPr/>
+        </p:nvSpPr>
+        <p:spPr>
+          <a:xfrm>
+            <a:off x="217714" y="255046"/>
+            <a:ext cx="11756571" cy="355354"/>
+          </a:xfrm>
+          <a:prstGeom prst="rect">
+            <a:avLst/>
+          </a:prstGeom>
+          <a:noFill/>
+        </p:spPr>
+        <p:txBody>
+          <a:bodyPr wrap="square">
+            <a:spAutoFit/>
+          </a:bodyPr>
+          <a:lstStyle/>
+          <a:p>
+            <a:pPr>
+              <a:lnSpc>
+                <a:spcPct val="150000"/>
+              </a:lnSpc>
+              <a:buNone/>
+            </a:pPr>
+            <a:r>
+              <a:rPr kumimoji="0" lang="en-US" altLang="en-US" sz="1300" b="0" i="0" u="none" strike="noStrike" cap="none" normalizeH="0" baseline="0">
+                <a:ln>
+                  <a:noFill/>
+                </a:ln>
+                <a:solidFill>
+                  <a:schemeClr val="tx1"/>
+                </a:solidFill>
+                <a:effectLst/>
+                <a:latin typeface="Arial" panose="020B0604020202020204" pitchFamily="34" charset="0"/>
+              </a:rPr>
+              <a:t>.</a:t>
+            </a:r>
+          </a:p>
+        </p:txBody>
+      </p:sp>
+    </p:spTree>
+    <p:extLst>
+      <p:ext uri="{BB962C8B-B14F-4D97-AF65-F5344CB8AC3E}">
+        <p14:creationId xmlns:p14="http://schemas.microsoft.com/office/powerpoint/2010/main" val="3965664072"/>
+      </p:ext>
+    </p:extLst>
+  </p:cSld>
+  <p:clrMapOvr>
+    <a:masterClrMapping/>
+  </p:clrMapOvr>
+</p:sld>
+</file>
+
+<file path=ppt/slides/slide9.xml><?xml version="1.0" encoding="utf-8"?>
+<p:sld xmlns:a="http://schemas.openxmlformats.org/drawingml/2006/main" xmlns:r="http://schemas.openxmlformats.org/officeDocument/2006/relationships" xmlns:p="http://schemas.openxmlformats.org/presentationml/2006/main">
+  <p:cSld>
+    <p:spTree>
+      <p:nvGrpSpPr>
+        <p:cNvPr id="1" name="">
+          <a:extLst>
+            <a:ext uri="{FF2B5EF4-FFF2-40B4-BE49-F238E27FC236}">
+              <a16:creationId xmlns:a16="http://schemas.microsoft.com/office/drawing/2014/main" id="{C750250E-2D3A-7312-A072-5E332D29C845}"/>
+            </a:ext>
+          </a:extLst>
+        </p:cNvPr>
+        <p:cNvGrpSpPr/>
+        <p:nvPr/>
+      </p:nvGrpSpPr>
+      <p:grpSpPr>
+        <a:xfrm>
+          <a:off x="0" y="0"/>
+          <a:ext cx="0" cy="0"/>
+          <a:chOff x="0" y="0"/>
+          <a:chExt cx="0" cy="0"/>
+        </a:xfrm>
+      </p:grpSpPr>
+      <p:sp>
+        <p:nvSpPr>
+          <p:cNvPr id="3" name="TextBox 2">
+            <a:extLst>
+              <a:ext uri="{FF2B5EF4-FFF2-40B4-BE49-F238E27FC236}">
+                <a16:creationId xmlns:a16="http://schemas.microsoft.com/office/drawing/2014/main" id="{4FBA1BF9-47A3-2607-6299-84C8AF939A62}"/>
+              </a:ext>
+            </a:extLst>
+          </p:cNvPr>
+          <p:cNvSpPr txBox="1"/>
+          <p:nvPr/>
+        </p:nvSpPr>
+        <p:spPr>
+          <a:xfrm>
+            <a:off x="217714" y="255046"/>
+            <a:ext cx="11756571" cy="355354"/>
+          </a:xfrm>
+          <a:prstGeom prst="rect">
+            <a:avLst/>
+          </a:prstGeom>
+          <a:noFill/>
+        </p:spPr>
+        <p:txBody>
+          <a:bodyPr wrap="square">
+            <a:spAutoFit/>
+          </a:bodyPr>
+          <a:lstStyle/>
+          <a:p>
+            <a:pPr>
+              <a:lnSpc>
+                <a:spcPct val="150000"/>
+              </a:lnSpc>
+              <a:buNone/>
+            </a:pPr>
+            <a:r>
+              <a:rPr kumimoji="0" lang="en-US" altLang="en-US" sz="1300" b="0" i="0" u="none" strike="noStrike" cap="none" normalizeH="0" baseline="0">
+                <a:ln>
+                  <a:noFill/>
+                </a:ln>
+                <a:solidFill>
+                  <a:schemeClr val="tx1"/>
+                </a:solidFill>
+                <a:effectLst/>
+                <a:latin typeface="Arial" panose="020B0604020202020204" pitchFamily="34" charset="0"/>
+              </a:rPr>
+              <a:t>.</a:t>
+            </a:r>
+          </a:p>
+        </p:txBody>
+      </p:sp>
+    </p:spTree>
+    <p:extLst>
+      <p:ext uri="{BB962C8B-B14F-4D97-AF65-F5344CB8AC3E}">
+        <p14:creationId xmlns:p14="http://schemas.microsoft.com/office/powerpoint/2010/main" val="1988632263"/>
       </p:ext>
     </p:extLst>
   </p:cSld>

</xml_diff>